<commit_message>
docs(audit): finalize presentation and technical document consistency audit
</commit_message>
<xml_diff>
--- a/docs/StockWise_AI_Hackathon_Presentation.pptx
+++ b/docs/StockWise_AI_Hackathon_Presentation.pptx
@@ -3149,7 +3149,7 @@
         <p:spPr>
           <a:xfrm>
             <a:off x="1097280" y="1645920"/>
-            <a:ext cx="9601200" cy="3200400"/>
+            <a:ext cx="9601200" cy="3291840"/>
           </a:xfrm>
           <a:prstGeom prst="rect">
             <a:avLst/>
@@ -3163,7 +3163,10 @@
           <a:lstStyle/>
           <a:p>
             <a:pPr>
-              <a:defRPr sz="1200" b="1">
+              <a:spcAft>
+                <a:spcPts val="800"/>
+              </a:spcAft>
+              <a:defRPr sz="1300" b="1">
                 <a:solidFill>
                   <a:srgbClr val="0284C7"/>
                 </a:solidFill>
@@ -3178,7 +3181,7 @@
               <a:spcAft>
                 <a:spcPts val="1400"/>
               </a:spcAft>
-              <a:defRPr sz="4400" b="1">
+              <a:defRPr sz="4600" b="1">
                 <a:solidFill>
                   <a:srgbClr val="FFFFFF"/>
                 </a:solidFill>
@@ -3240,7 +3243,7 @@
           <a:lstStyle/>
           <a:p>
             <a:pPr>
-              <a:defRPr sz="1100">
+              <a:defRPr sz="1150">
                 <a:solidFill>
                   <a:srgbClr val="94A3B8"/>
                 </a:solidFill>
@@ -3293,7 +3296,7 @@
           <a:lstStyle/>
           <a:p>
             <a:pPr>
-              <a:defRPr sz="1000" b="1">
+              <a:defRPr sz="1100" b="1">
                 <a:solidFill>
                   <a:srgbClr val="0284C7"/>
                 </a:solidFill>
@@ -3313,8 +3316,8 @@
         </p:nvSpPr>
         <p:spPr>
           <a:xfrm>
-            <a:off x="731520" y="640080"/>
-            <a:ext cx="10515600" cy="548640"/>
+            <a:off x="731520" y="658368"/>
+            <a:ext cx="10515600" cy="594360"/>
           </a:xfrm>
           <a:prstGeom prst="rect">
             <a:avLst/>
@@ -3328,7 +3331,7 @@
           <a:lstStyle/>
           <a:p>
             <a:pPr>
-              <a:defRPr sz="2200" b="1">
+              <a:defRPr sz="2300" b="1">
                 <a:solidFill>
                   <a:srgbClr val="0F172A"/>
                 </a:solidFill>
@@ -3411,7 +3414,7 @@
               <a:spcAft>
                 <a:spcPts val="800"/>
               </a:spcAft>
-              <a:defRPr sz="1500" b="1">
+              <a:defRPr sz="1600" b="1">
                 <a:solidFill>
                   <a:srgbClr val="0F172A"/>
                 </a:solidFill>
@@ -3423,7 +3426,7 @@
           </a:p>
           <a:p>
             <a:pPr>
-              <a:defRPr sz="1050" b="1">
+              <a:defRPr sz="1100" b="1">
                 <a:solidFill>
                   <a:srgbClr val="B91C1C"/>
                 </a:solidFill>
@@ -3438,7 +3441,7 @@
               <a:spcAft>
                 <a:spcPts val="400"/>
               </a:spcAft>
-              <a:defRPr sz="950">
+              <a:defRPr sz="1000">
                 <a:solidFill>
                   <a:srgbClr val="1E293B"/>
                 </a:solidFill>
@@ -3450,7 +3453,7 @@
           </a:p>
           <a:p>
             <a:pPr>
-              <a:defRPr sz="1050" b="1">
+              <a:defRPr sz="1100" b="1">
                 <a:solidFill>
                   <a:srgbClr val="B91C1C"/>
                 </a:solidFill>
@@ -3465,7 +3468,7 @@
               <a:spcAft>
                 <a:spcPts val="400"/>
               </a:spcAft>
-              <a:defRPr sz="950">
+              <a:defRPr sz="1000">
                 <a:solidFill>
                   <a:srgbClr val="1E293B"/>
                 </a:solidFill>
@@ -3477,7 +3480,7 @@
           </a:p>
           <a:p>
             <a:pPr>
-              <a:defRPr sz="1050" b="1">
+              <a:defRPr sz="1100" b="1">
                 <a:solidFill>
                   <a:srgbClr val="B91C1C"/>
                 </a:solidFill>
@@ -3492,7 +3495,7 @@
               <a:spcAft>
                 <a:spcPts val="400"/>
               </a:spcAft>
-              <a:defRPr sz="950">
+              <a:defRPr sz="1000">
                 <a:solidFill>
                   <a:srgbClr val="1E293B"/>
                 </a:solidFill>
@@ -3504,7 +3507,7 @@
           </a:p>
           <a:p>
             <a:pPr>
-              <a:defRPr sz="1050" b="1">
+              <a:defRPr sz="1100" b="1">
                 <a:solidFill>
                   <a:srgbClr val="B91C1C"/>
                 </a:solidFill>
@@ -3519,7 +3522,7 @@
               <a:spcAft>
                 <a:spcPts val="400"/>
               </a:spcAft>
-              <a:defRPr sz="950">
+              <a:defRPr sz="1000">
                 <a:solidFill>
                   <a:srgbClr val="1E293B"/>
                 </a:solidFill>
@@ -3531,7 +3534,7 @@
           </a:p>
           <a:p>
             <a:pPr>
-              <a:defRPr sz="1050" b="1">
+              <a:defRPr sz="1100" b="1">
                 <a:solidFill>
                   <a:srgbClr val="B91C1C"/>
                 </a:solidFill>
@@ -3546,7 +3549,7 @@
               <a:spcAft>
                 <a:spcPts val="400"/>
               </a:spcAft>
-              <a:defRPr sz="950">
+              <a:defRPr sz="1000">
                 <a:solidFill>
                   <a:srgbClr val="1E293B"/>
                 </a:solidFill>
@@ -3629,7 +3632,7 @@
               <a:spcAft>
                 <a:spcPts val="800"/>
               </a:spcAft>
-              <a:defRPr sz="1500" b="1">
+              <a:defRPr sz="1600" b="1">
                 <a:solidFill>
                   <a:srgbClr val="0F172A"/>
                 </a:solidFill>
@@ -3641,7 +3644,7 @@
           </a:p>
           <a:p>
             <a:pPr>
-              <a:defRPr sz="1050" b="1">
+              <a:defRPr sz="1100" b="1">
                 <a:solidFill>
                   <a:srgbClr val="0284C7"/>
                 </a:solidFill>
@@ -3656,7 +3659,7 @@
               <a:spcAft>
                 <a:spcPts val="400"/>
               </a:spcAft>
-              <a:defRPr sz="950">
+              <a:defRPr sz="1000">
                 <a:solidFill>
                   <a:srgbClr val="1E293B"/>
                 </a:solidFill>
@@ -3668,7 +3671,7 @@
           </a:p>
           <a:p>
             <a:pPr>
-              <a:defRPr sz="1050" b="1">
+              <a:defRPr sz="1100" b="1">
                 <a:solidFill>
                   <a:srgbClr val="0284C7"/>
                 </a:solidFill>
@@ -3683,7 +3686,7 @@
               <a:spcAft>
                 <a:spcPts val="400"/>
               </a:spcAft>
-              <a:defRPr sz="950">
+              <a:defRPr sz="1000">
                 <a:solidFill>
                   <a:srgbClr val="1E293B"/>
                 </a:solidFill>
@@ -3695,7 +3698,7 @@
           </a:p>
           <a:p>
             <a:pPr>
-              <a:defRPr sz="1050" b="1">
+              <a:defRPr sz="1100" b="1">
                 <a:solidFill>
                   <a:srgbClr val="0284C7"/>
                 </a:solidFill>
@@ -3710,7 +3713,7 @@
               <a:spcAft>
                 <a:spcPts val="400"/>
               </a:spcAft>
-              <a:defRPr sz="950">
+              <a:defRPr sz="1000">
                 <a:solidFill>
                   <a:srgbClr val="1E293B"/>
                 </a:solidFill>
@@ -3722,7 +3725,7 @@
           </a:p>
           <a:p>
             <a:pPr>
-              <a:defRPr sz="1050" b="1">
+              <a:defRPr sz="1100" b="1">
                 <a:solidFill>
                   <a:srgbClr val="0284C7"/>
                 </a:solidFill>
@@ -3737,7 +3740,7 @@
               <a:spcAft>
                 <a:spcPts val="400"/>
               </a:spcAft>
-              <a:defRPr sz="950">
+              <a:defRPr sz="1000">
                 <a:solidFill>
                   <a:srgbClr val="1E293B"/>
                 </a:solidFill>
@@ -3749,7 +3752,7 @@
           </a:p>
           <a:p>
             <a:pPr>
-              <a:defRPr sz="1050" b="1">
+              <a:defRPr sz="1100" b="1">
                 <a:solidFill>
                   <a:srgbClr val="0284C7"/>
                 </a:solidFill>
@@ -3764,7 +3767,7 @@
               <a:spcAft>
                 <a:spcPts val="400"/>
               </a:spcAft>
-              <a:defRPr sz="950">
+              <a:defRPr sz="1000">
                 <a:solidFill>
                   <a:srgbClr val="1E293B"/>
                 </a:solidFill>
@@ -3817,7 +3820,7 @@
           <a:lstStyle/>
           <a:p>
             <a:pPr>
-              <a:defRPr sz="1000" b="1">
+              <a:defRPr sz="1100" b="1">
                 <a:solidFill>
                   <a:srgbClr val="0284C7"/>
                 </a:solidFill>
@@ -3837,8 +3840,8 @@
         </p:nvSpPr>
         <p:spPr>
           <a:xfrm>
-            <a:off x="731520" y="640080"/>
-            <a:ext cx="10515600" cy="548640"/>
+            <a:off x="731520" y="658368"/>
+            <a:ext cx="10515600" cy="594360"/>
           </a:xfrm>
           <a:prstGeom prst="rect">
             <a:avLst/>
@@ -3852,7 +3855,7 @@
           <a:lstStyle/>
           <a:p>
             <a:pPr>
-              <a:defRPr sz="2200" b="1">
+              <a:defRPr sz="2300" b="1">
                 <a:solidFill>
                   <a:srgbClr val="0F172A"/>
                 </a:solidFill>
@@ -3935,7 +3938,7 @@
               <a:spcAft>
                 <a:spcPts val="800"/>
               </a:spcAft>
-              <a:defRPr sz="1500" b="1">
+              <a:defRPr sz="1600" b="1">
                 <a:solidFill>
                   <a:srgbClr val="0F172A"/>
                 </a:solidFill>
@@ -4030,7 +4033,7 @@
               <a:spcAft>
                 <a:spcPts val="800"/>
               </a:spcAft>
-              <a:defRPr sz="1500" b="1">
+              <a:defRPr sz="1600" b="1">
                 <a:solidFill>
                   <a:srgbClr val="0F172A"/>
                 </a:solidFill>
@@ -4125,7 +4128,7 @@
               <a:spcAft>
                 <a:spcPts val="800"/>
               </a:spcAft>
-              <a:defRPr sz="1500" b="1">
+              <a:defRPr sz="1600" b="1">
                 <a:solidFill>
                   <a:srgbClr val="0F172A"/>
                 </a:solidFill>
@@ -4220,7 +4223,7 @@
               <a:spcAft>
                 <a:spcPts val="800"/>
               </a:spcAft>
-              <a:defRPr sz="1500" b="1">
+              <a:defRPr sz="1600" b="1">
                 <a:solidFill>
                   <a:srgbClr val="0F172A"/>
                 </a:solidFill>
@@ -4285,7 +4288,7 @@
           <a:lstStyle/>
           <a:p>
             <a:pPr>
-              <a:defRPr sz="1000" b="1">
+              <a:defRPr sz="1100" b="1">
                 <a:solidFill>
                   <a:srgbClr val="0284C7"/>
                 </a:solidFill>
@@ -4305,8 +4308,8 @@
         </p:nvSpPr>
         <p:spPr>
           <a:xfrm>
-            <a:off x="731520" y="640080"/>
-            <a:ext cx="10515600" cy="548640"/>
+            <a:off x="731520" y="658368"/>
+            <a:ext cx="10515600" cy="594360"/>
           </a:xfrm>
           <a:prstGeom prst="rect">
             <a:avLst/>
@@ -4320,7 +4323,7 @@
           <a:lstStyle/>
           <a:p>
             <a:pPr>
-              <a:defRPr sz="2200" b="1">
+              <a:defRPr sz="2300" b="1">
                 <a:solidFill>
                   <a:srgbClr val="0F172A"/>
                 </a:solidFill>
@@ -4340,8 +4343,8 @@
         </p:nvSpPr>
         <p:spPr>
           <a:xfrm>
-            <a:off x="731520" y="1645920"/>
-            <a:ext cx="2011680" cy="4389120"/>
+            <a:off x="731520" y="1554480"/>
+            <a:ext cx="2011680" cy="4572000"/>
           </a:xfrm>
           <a:prstGeom prst="roundRect">
             <a:avLst/>
@@ -4385,8 +4388,8 @@
         </p:nvSpPr>
         <p:spPr>
           <a:xfrm>
-            <a:off x="868680" y="1828800"/>
-            <a:ext cx="1737360" cy="3931920"/>
+            <a:off x="868680" y="1783080"/>
+            <a:ext cx="1737360" cy="4114800"/>
           </a:xfrm>
           <a:prstGeom prst="rect">
             <a:avLst/>
@@ -4401,9 +4404,9 @@
           <a:p>
             <a:pPr>
               <a:spcAft>
-                <a:spcPts val="1000"/>
+                <a:spcPts val="1200"/>
               </a:spcAft>
-              <a:defRPr sz="1300" b="1">
+              <a:defRPr sz="1350" b="1">
                 <a:solidFill>
                   <a:srgbClr val="0284C7"/>
                 </a:solidFill>
@@ -4415,7 +4418,7 @@
           </a:p>
           <a:p>
             <a:pPr>
-              <a:defRPr sz="1100">
+              <a:defRPr sz="1150">
                 <a:solidFill>
                   <a:srgbClr val="1E293B"/>
                 </a:solidFill>
@@ -4435,8 +4438,8 @@
         </p:nvSpPr>
         <p:spPr>
           <a:xfrm>
-            <a:off x="2880360" y="1645920"/>
-            <a:ext cx="2011680" cy="4389120"/>
+            <a:off x="2880360" y="1554480"/>
+            <a:ext cx="2011680" cy="4572000"/>
           </a:xfrm>
           <a:prstGeom prst="roundRect">
             <a:avLst/>
@@ -4480,8 +4483,8 @@
         </p:nvSpPr>
         <p:spPr>
           <a:xfrm>
-            <a:off x="3017520" y="1828800"/>
-            <a:ext cx="1737360" cy="3931920"/>
+            <a:off x="3017520" y="1783080"/>
+            <a:ext cx="1737360" cy="4114800"/>
           </a:xfrm>
           <a:prstGeom prst="rect">
             <a:avLst/>
@@ -4496,9 +4499,9 @@
           <a:p>
             <a:pPr>
               <a:spcAft>
-                <a:spcPts val="1000"/>
+                <a:spcPts val="1200"/>
               </a:spcAft>
-              <a:defRPr sz="1300" b="1">
+              <a:defRPr sz="1350" b="1">
                 <a:solidFill>
                   <a:srgbClr val="0284C7"/>
                 </a:solidFill>
@@ -4510,14 +4513,14 @@
           </a:p>
           <a:p>
             <a:pPr>
-              <a:defRPr sz="1100">
+              <a:defRPr sz="1150">
                 <a:solidFill>
                   <a:srgbClr val="1E293B"/>
                 </a:solidFill>
               </a:defRPr>
             </a:pPr>
             <a:r>
-              <a:t>Lead-time demand + dynamic safety stock (z=1.65) to compute exact carton replenishment thresholds.</a:t>
+              <a:t>Lead-time demand + dynamic safety stock to compute exact carton replenishment thresholds.</a:t>
             </a:r>
           </a:p>
         </p:txBody>
@@ -4530,8 +4533,8 @@
         </p:nvSpPr>
         <p:spPr>
           <a:xfrm>
-            <a:off x="5029200" y="1645920"/>
-            <a:ext cx="2011680" cy="4389120"/>
+            <a:off x="5029200" y="1554480"/>
+            <a:ext cx="2011680" cy="4572000"/>
           </a:xfrm>
           <a:prstGeom prst="roundRect">
             <a:avLst/>
@@ -4575,8 +4578,8 @@
         </p:nvSpPr>
         <p:spPr>
           <a:xfrm>
-            <a:off x="5166360" y="1828800"/>
-            <a:ext cx="1737360" cy="3931920"/>
+            <a:off x="5166360" y="1783080"/>
+            <a:ext cx="1737360" cy="4114800"/>
           </a:xfrm>
           <a:prstGeom prst="rect">
             <a:avLst/>
@@ -4591,9 +4594,9 @@
           <a:p>
             <a:pPr>
               <a:spcAft>
-                <a:spcPts val="1000"/>
+                <a:spcPts val="1200"/>
               </a:spcAft>
-              <a:defRPr sz="1300" b="1">
+              <a:defRPr sz="1350" b="1">
                 <a:solidFill>
                   <a:srgbClr val="0284C7"/>
                 </a:solidFill>
@@ -4605,7 +4608,7 @@
           </a:p>
           <a:p>
             <a:pPr>
-              <a:defRPr sz="1100">
+              <a:defRPr sz="1150">
                 <a:solidFill>
                   <a:srgbClr val="1E293B"/>
                 </a:solidFill>
@@ -4625,8 +4628,8 @@
         </p:nvSpPr>
         <p:spPr>
           <a:xfrm>
-            <a:off x="7178040" y="1645920"/>
-            <a:ext cx="2011680" cy="4389120"/>
+            <a:off x="7178040" y="1554480"/>
+            <a:ext cx="2011680" cy="4572000"/>
           </a:xfrm>
           <a:prstGeom prst="roundRect">
             <a:avLst/>
@@ -4670,8 +4673,8 @@
         </p:nvSpPr>
         <p:spPr>
           <a:xfrm>
-            <a:off x="7315200" y="1828800"/>
-            <a:ext cx="1737360" cy="3931920"/>
+            <a:off x="7315200" y="1783080"/>
+            <a:ext cx="1737360" cy="4114800"/>
           </a:xfrm>
           <a:prstGeom prst="rect">
             <a:avLst/>
@@ -4686,9 +4689,9 @@
           <a:p>
             <a:pPr>
               <a:spcAft>
-                <a:spcPts val="1000"/>
+                <a:spcPts val="1200"/>
               </a:spcAft>
-              <a:defRPr sz="1300" b="1">
+              <a:defRPr sz="1350" b="1">
                 <a:solidFill>
                   <a:srgbClr val="0284C7"/>
                 </a:solidFill>
@@ -4700,7 +4703,7 @@
           </a:p>
           <a:p>
             <a:pPr>
-              <a:defRPr sz="1100">
+              <a:defRPr sz="1150">
                 <a:solidFill>
                   <a:srgbClr val="1E293B"/>
                 </a:solidFill>
@@ -4720,8 +4723,8 @@
         </p:nvSpPr>
         <p:spPr>
           <a:xfrm>
-            <a:off x="9326880" y="1645920"/>
-            <a:ext cx="2011680" cy="4389120"/>
+            <a:off x="9326880" y="1554480"/>
+            <a:ext cx="2011680" cy="4572000"/>
           </a:xfrm>
           <a:prstGeom prst="roundRect">
             <a:avLst/>
@@ -4765,8 +4768,8 @@
         </p:nvSpPr>
         <p:spPr>
           <a:xfrm>
-            <a:off x="9464040" y="1828800"/>
-            <a:ext cx="1737360" cy="3931920"/>
+            <a:off x="9464040" y="1783080"/>
+            <a:ext cx="1737360" cy="4114800"/>
           </a:xfrm>
           <a:prstGeom prst="rect">
             <a:avLst/>
@@ -4781,9 +4784,9 @@
           <a:p>
             <a:pPr>
               <a:spcAft>
-                <a:spcPts val="1000"/>
+                <a:spcPts val="1200"/>
               </a:spcAft>
-              <a:defRPr sz="1300" b="1">
+              <a:defRPr sz="1350" b="1">
                 <a:solidFill>
                   <a:srgbClr val="0284C7"/>
                 </a:solidFill>
@@ -4795,7 +4798,7 @@
           </a:p>
           <a:p>
             <a:pPr>
-              <a:defRPr sz="1100">
+              <a:defRPr sz="1150">
                 <a:solidFill>
                   <a:srgbClr val="1E293B"/>
                 </a:solidFill>
@@ -4848,7 +4851,7 @@
           <a:lstStyle/>
           <a:p>
             <a:pPr>
-              <a:defRPr sz="1000" b="1">
+              <a:defRPr sz="1100" b="1">
                 <a:solidFill>
                   <a:srgbClr val="0284C7"/>
                 </a:solidFill>
@@ -4868,8 +4871,8 @@
         </p:nvSpPr>
         <p:spPr>
           <a:xfrm>
-            <a:off x="731520" y="640080"/>
-            <a:ext cx="10515600" cy="548640"/>
+            <a:off x="731520" y="658368"/>
+            <a:ext cx="10515600" cy="594360"/>
           </a:xfrm>
           <a:prstGeom prst="rect">
             <a:avLst/>
@@ -4883,7 +4886,7 @@
           <a:lstStyle/>
           <a:p>
             <a:pPr>
-              <a:defRPr sz="2200" b="1">
+              <a:defRPr sz="2300" b="1">
                 <a:solidFill>
                   <a:srgbClr val="0F172A"/>
                 </a:solidFill>
@@ -4963,7 +4966,7 @@
           <a:lstStyle/>
           <a:p>
             <a:pPr>
-              <a:defRPr sz="1200" b="1">
+              <a:defRPr sz="1250" b="1">
                 <a:solidFill>
                   <a:srgbClr val="0F172A"/>
                 </a:solidFill>
@@ -4975,7 +4978,7 @@
           </a:p>
           <a:p>
             <a:pPr>
-              <a:defRPr sz="1000">
+              <a:defRPr sz="1050">
                 <a:solidFill>
                   <a:srgbClr val="1E293B"/>
                 </a:solidFill>
@@ -5055,7 +5058,7 @@
           <a:lstStyle/>
           <a:p>
             <a:pPr>
-              <a:defRPr sz="1200" b="1">
+              <a:defRPr sz="1250" b="1">
                 <a:solidFill>
                   <a:srgbClr val="0F172A"/>
                 </a:solidFill>
@@ -5067,7 +5070,7 @@
           </a:p>
           <a:p>
             <a:pPr>
-              <a:defRPr sz="1000">
+              <a:defRPr sz="1050">
                 <a:solidFill>
                   <a:srgbClr val="1E293B"/>
                 </a:solidFill>
@@ -5147,7 +5150,7 @@
           <a:lstStyle/>
           <a:p>
             <a:pPr>
-              <a:defRPr sz="1200" b="1">
+              <a:defRPr sz="1250" b="1">
                 <a:solidFill>
                   <a:srgbClr val="0F172A"/>
                 </a:solidFill>
@@ -5159,7 +5162,7 @@
           </a:p>
           <a:p>
             <a:pPr>
-              <a:defRPr sz="1000">
+              <a:defRPr sz="1050">
                 <a:solidFill>
                   <a:srgbClr val="1E293B"/>
                 </a:solidFill>
@@ -5239,7 +5242,7 @@
           <a:lstStyle/>
           <a:p>
             <a:pPr>
-              <a:defRPr sz="1200" b="1">
+              <a:defRPr sz="1250" b="1">
                 <a:solidFill>
                   <a:srgbClr val="0F172A"/>
                 </a:solidFill>
@@ -5251,7 +5254,7 @@
           </a:p>
           <a:p>
             <a:pPr>
-              <a:defRPr sz="1000">
+              <a:defRPr sz="1050">
                 <a:solidFill>
                   <a:srgbClr val="1E293B"/>
                 </a:solidFill>
@@ -5331,7 +5334,7 @@
           <a:lstStyle/>
           <a:p>
             <a:pPr>
-              <a:defRPr sz="1200" b="1">
+              <a:defRPr sz="1250" b="1">
                 <a:solidFill>
                   <a:srgbClr val="0F172A"/>
                 </a:solidFill>
@@ -5343,7 +5346,7 @@
           </a:p>
           <a:p>
             <a:pPr>
-              <a:defRPr sz="1000">
+              <a:defRPr sz="1050">
                 <a:solidFill>
                   <a:srgbClr val="1E293B"/>
                 </a:solidFill>
@@ -5438,7 +5441,7 @@
           </a:p>
           <a:p>
             <a:pPr>
-              <a:defRPr sz="1100" b="1">
+              <a:defRPr sz="1150" b="1">
                 <a:solidFill>
                   <a:srgbClr val="0284C7"/>
                 </a:solidFill>
@@ -5453,7 +5456,7 @@
               <a:spcAft>
                 <a:spcPts val="800"/>
               </a:spcAft>
-              <a:defRPr sz="1000">
+              <a:defRPr sz="1050">
                 <a:solidFill>
                   <a:srgbClr val="1E293B"/>
                 </a:solidFill>
@@ -5465,7 +5468,7 @@
           </a:p>
           <a:p>
             <a:pPr>
-              <a:defRPr sz="1100" b="1">
+              <a:defRPr sz="1150" b="1">
                 <a:solidFill>
                   <a:srgbClr val="0284C7"/>
                 </a:solidFill>
@@ -5480,7 +5483,7 @@
               <a:spcAft>
                 <a:spcPts val="800"/>
               </a:spcAft>
-              <a:defRPr sz="1000">
+              <a:defRPr sz="1050">
                 <a:solidFill>
                   <a:srgbClr val="1E293B"/>
                 </a:solidFill>
@@ -5492,7 +5495,7 @@
           </a:p>
           <a:p>
             <a:pPr>
-              <a:defRPr sz="1100" b="1">
+              <a:defRPr sz="1150" b="1">
                 <a:solidFill>
                   <a:srgbClr val="0284C7"/>
                 </a:solidFill>
@@ -5507,7 +5510,7 @@
               <a:spcAft>
                 <a:spcPts val="800"/>
               </a:spcAft>
-              <a:defRPr sz="1000">
+              <a:defRPr sz="1050">
                 <a:solidFill>
                   <a:srgbClr val="1E293B"/>
                 </a:solidFill>
@@ -5519,7 +5522,7 @@
           </a:p>
           <a:p>
             <a:pPr>
-              <a:defRPr sz="1100" b="1">
+              <a:defRPr sz="1150" b="1">
                 <a:solidFill>
                   <a:srgbClr val="0284C7"/>
                 </a:solidFill>
@@ -5534,7 +5537,7 @@
               <a:spcAft>
                 <a:spcPts val="800"/>
               </a:spcAft>
-              <a:defRPr sz="1000">
+              <a:defRPr sz="1050">
                 <a:solidFill>
                   <a:srgbClr val="1E293B"/>
                 </a:solidFill>
@@ -5587,7 +5590,7 @@
           <a:lstStyle/>
           <a:p>
             <a:pPr>
-              <a:defRPr sz="1000" b="1">
+              <a:defRPr sz="1100" b="1">
                 <a:solidFill>
                   <a:srgbClr val="0284C7"/>
                 </a:solidFill>
@@ -5607,8 +5610,8 @@
         </p:nvSpPr>
         <p:spPr>
           <a:xfrm>
-            <a:off x="731520" y="640080"/>
-            <a:ext cx="10515600" cy="548640"/>
+            <a:off x="731520" y="658368"/>
+            <a:ext cx="10515600" cy="594360"/>
           </a:xfrm>
           <a:prstGeom prst="rect">
             <a:avLst/>
@@ -5622,7 +5625,7 @@
           <a:lstStyle/>
           <a:p>
             <a:pPr>
-              <a:defRPr sz="2200" b="1">
+              <a:defRPr sz="2300" b="1">
                 <a:solidFill>
                   <a:srgbClr val="0F172A"/>
                 </a:solidFill>
@@ -5718,9 +5721,9 @@
           <a:p>
             <a:pPr>
               <a:spcAft>
-                <a:spcPts val="800"/>
+                <a:spcPts val="900"/>
               </a:spcAft>
-              <a:defRPr sz="1050">
+              <a:defRPr sz="1100">
                 <a:solidFill>
                   <a:srgbClr val="1E293B"/>
                 </a:solidFill>
@@ -5733,9 +5736,9 @@
           <a:p>
             <a:pPr>
               <a:spcAft>
-                <a:spcPts val="800"/>
+                <a:spcPts val="900"/>
               </a:spcAft>
-              <a:defRPr sz="1050">
+              <a:defRPr sz="1100">
                 <a:solidFill>
                   <a:srgbClr val="1E293B"/>
                 </a:solidFill>
@@ -5748,24 +5751,24 @@
           <a:p>
             <a:pPr>
               <a:spcAft>
-                <a:spcPts val="800"/>
+                <a:spcPts val="900"/>
               </a:spcAft>
-              <a:defRPr sz="1050">
+              <a:defRPr sz="1100">
                 <a:solidFill>
                   <a:srgbClr val="1E293B"/>
                 </a:solidFill>
               </a:defRPr>
             </a:pPr>
             <a:r>
-              <a:t>• Dynamic Safety Stock (SS): SS = z x sigma x sqrt(L) with 95% service level factor (z=1.65). Buffers demand &amp; lead-time variance. Network sum: 10,744.93 units.</a:t>
+              <a:t>• Dynamic Safety Stock (SS): SS = z x sigma x sqrt(L) under standard cycle-service level assumption (z=1.65, 95% cycle target; not guaranteed volume fill rate). Network sum: 10,744.93 units.</a:t>
             </a:r>
           </a:p>
           <a:p>
             <a:pPr>
               <a:spcAft>
-                <a:spcPts val="800"/>
+                <a:spcPts val="900"/>
               </a:spcAft>
-              <a:defRPr sz="1050">
+              <a:defRPr sz="1100">
                 <a:solidFill>
                   <a:srgbClr val="1E293B"/>
                 </a:solidFill>
@@ -5860,7 +5863,7 @@
           </a:p>
           <a:p>
             <a:pPr>
-              <a:defRPr sz="1100" b="1">
+              <a:defRPr sz="1150" b="1">
                 <a:solidFill>
                   <a:srgbClr val="0284C7"/>
                 </a:solidFill>
@@ -5873,9 +5876,9 @@
           <a:p>
             <a:pPr>
               <a:spcAft>
-                <a:spcPts val="600"/>
+                <a:spcPts val="700"/>
               </a:spcAft>
-              <a:defRPr sz="1050">
+              <a:defRPr sz="1100">
                 <a:solidFill>
                   <a:srgbClr val="1E293B"/>
                 </a:solidFill>
@@ -5887,7 +5890,7 @@
           </a:p>
           <a:p>
             <a:pPr>
-              <a:defRPr sz="1100" b="1">
+              <a:defRPr sz="1150" b="1">
                 <a:solidFill>
                   <a:srgbClr val="0284C7"/>
                 </a:solidFill>
@@ -5900,9 +5903,9 @@
           <a:p>
             <a:pPr>
               <a:spcAft>
-                <a:spcPts val="600"/>
+                <a:spcPts val="700"/>
               </a:spcAft>
-              <a:defRPr sz="1050">
+              <a:defRPr sz="1100">
                 <a:solidFill>
                   <a:srgbClr val="1E293B"/>
                 </a:solidFill>
@@ -5914,7 +5917,7 @@
           </a:p>
           <a:p>
             <a:pPr>
-              <a:defRPr sz="1100" b="1">
+              <a:defRPr sz="1150" b="1">
                 <a:solidFill>
                   <a:srgbClr val="0284C7"/>
                 </a:solidFill>
@@ -5927,9 +5930,9 @@
           <a:p>
             <a:pPr>
               <a:spcAft>
-                <a:spcPts val="600"/>
+                <a:spcPts val="700"/>
               </a:spcAft>
-              <a:defRPr sz="1050">
+              <a:defRPr sz="1100">
                 <a:solidFill>
                   <a:srgbClr val="1E293B"/>
                 </a:solidFill>
@@ -5941,7 +5944,7 @@
           </a:p>
           <a:p>
             <a:pPr>
-              <a:defRPr sz="1100" b="1">
+              <a:defRPr sz="1150" b="1">
                 <a:solidFill>
                   <a:srgbClr val="0284C7"/>
                 </a:solidFill>
@@ -5954,9 +5957,9 @@
           <a:p>
             <a:pPr>
               <a:spcAft>
-                <a:spcPts val="600"/>
+                <a:spcPts val="700"/>
               </a:spcAft>
-              <a:defRPr sz="1050">
+              <a:defRPr sz="1100">
                 <a:solidFill>
                   <a:srgbClr val="1E293B"/>
                 </a:solidFill>
@@ -6009,7 +6012,7 @@
           <a:lstStyle/>
           <a:p>
             <a:pPr>
-              <a:defRPr sz="1000" b="1">
+              <a:defRPr sz="1100" b="1">
                 <a:solidFill>
                   <a:srgbClr val="0284C7"/>
                 </a:solidFill>
@@ -6029,8 +6032,8 @@
         </p:nvSpPr>
         <p:spPr>
           <a:xfrm>
-            <a:off x="731520" y="640080"/>
-            <a:ext cx="10515600" cy="548640"/>
+            <a:off x="731520" y="658368"/>
+            <a:ext cx="10515600" cy="594360"/>
           </a:xfrm>
           <a:prstGeom prst="rect">
             <a:avLst/>
@@ -6044,7 +6047,7 @@
           <a:lstStyle/>
           <a:p>
             <a:pPr>
-              <a:defRPr sz="2200" b="1">
+              <a:defRPr sz="2300" b="1">
                 <a:solidFill>
                   <a:srgbClr val="0F172A"/>
                 </a:solidFill>
@@ -6065,7 +6068,7 @@
         <p:spPr>
           <a:xfrm>
             <a:off x="731520" y="1371600"/>
-            <a:ext cx="3383280" cy="4892040"/>
+            <a:ext cx="3383280" cy="3931920"/>
           </a:xfrm>
           <a:prstGeom prst="roundRect">
             <a:avLst/>
@@ -6110,7 +6113,7 @@
         <p:spPr>
           <a:xfrm>
             <a:off x="914400" y="1554480"/>
-            <a:ext cx="3017520" cy="4480560"/>
+            <a:ext cx="3017520" cy="3566160"/>
           </a:xfrm>
           <a:prstGeom prst="rect">
             <a:avLst/>
@@ -6125,7 +6128,7 @@
           <a:p>
             <a:pPr>
               <a:spcAft>
-                <a:spcPts val="400"/>
+                <a:spcPts val="300"/>
               </a:spcAft>
               <a:defRPr sz="1500" b="1">
                 <a:solidFill>
@@ -6140,9 +6143,9 @@
           <a:p>
             <a:pPr>
               <a:spcAft>
-                <a:spcPts val="1000"/>
+                <a:spcPts val="800"/>
               </a:spcAft>
-              <a:defRPr sz="1000">
+              <a:defRPr sz="1050">
                 <a:solidFill>
                   <a:srgbClr val="64748B"/>
                 </a:solidFill>
@@ -6155,71 +6158,32 @@
           <a:p>
             <a:pPr>
               <a:spcAft>
-                <a:spcPts val="1000"/>
+                <a:spcPts val="800"/>
               </a:spcAft>
-              <a:defRPr sz="950" b="1">
+              <a:defRPr sz="1050" b="1">
                 <a:solidFill>
                   <a:srgbClr val="0284C7"/>
                 </a:solidFill>
               </a:defRPr>
             </a:pPr>
             <a:r>
-              <a:t>min sum(c_wd * x) + sum(2 * P * u)</a:t>
+              <a:t>min sum(c_wd * x) + sum(2*P * u)</a:t>
             </a:r>
             <a:br/>
             <a:r>
-              <a:t>s.t. sum(x) &gt;= 80% Total Demand</a:t>
-            </a:r>
-          </a:p>
-          <a:p>
-            <a:pPr>
-              <a:spcAft>
-                <a:spcPts val="1200"/>
-              </a:spcAft>
-              <a:defRPr sz="1000">
+              <a:t>s.t. sum(x) &gt;= ceil(0.80 * Demand)</a:t>
+            </a:r>
+          </a:p>
+          <a:p>
+            <a:pPr>
+              <a:defRPr sz="1050">
                 <a:solidFill>
                   <a:srgbClr val="1E293B"/>
                 </a:solidFill>
               </a:defRPr>
             </a:pPr>
             <a:r>
-              <a:t>Optimizes logistics efficiency while preventing arbitrary network starvation.</a:t>
-            </a:r>
-          </a:p>
-          <a:p>
-            <a:pPr>
-              <a:defRPr sz="900">
-                <a:solidFill>
-                  <a:srgbClr val="1E293B"/>
-                </a:solidFill>
-              </a:defRPr>
-            </a:pPr>
-            <a:r>
-              <a:t>Hard Constraints Enforced:</a:t>
-            </a:r>
-            <a:br/>
-            <a:r>
-              <a:t>• Warehouse usable supply bounds</a:t>
-            </a:r>
-            <a:br/>
-            <a:r>
-              <a:t>• Destination receiving caps (3,000 u/day)</a:t>
-            </a:r>
-            <a:br/>
-            <a:r>
-              <a:t>• Warehouse dispatch caps (15,000 u/day)</a:t>
-            </a:r>
-            <a:br/>
-            <a:r>
-              <a:t>• Active route &amp; lead-time cutoffs</a:t>
-            </a:r>
-            <a:br/>
-            <a:r>
-              <a:t>• Batch arrival shelf-life feasibility</a:t>
-            </a:r>
-            <a:br/>
-            <a:r>
-              <a:t>• Non-negative integers (x in Z+)</a:t>
+              <a:t>2*P unmet penalty. Bypassed if unconstrained opt-in. Trims high-cost lanes while exceeding 80% floor (delivers 90.18%).</a:t>
             </a:r>
           </a:p>
         </p:txBody>
@@ -6233,7 +6197,7 @@
         <p:spPr>
           <a:xfrm>
             <a:off x="4297680" y="1371600"/>
-            <a:ext cx="3383280" cy="4892040"/>
+            <a:ext cx="3383280" cy="3931920"/>
           </a:xfrm>
           <a:prstGeom prst="roundRect">
             <a:avLst/>
@@ -6278,7 +6242,7 @@
         <p:spPr>
           <a:xfrm>
             <a:off x="4480560" y="1554480"/>
-            <a:ext cx="3017520" cy="4480560"/>
+            <a:ext cx="3017520" cy="3566160"/>
           </a:xfrm>
           <a:prstGeom prst="rect">
             <a:avLst/>
@@ -6293,7 +6257,7 @@
           <a:p>
             <a:pPr>
               <a:spcAft>
-                <a:spcPts val="400"/>
+                <a:spcPts val="300"/>
               </a:spcAft>
               <a:defRPr sz="1500" b="1">
                 <a:solidFill>
@@ -6308,24 +6272,24 @@
           <a:p>
             <a:pPr>
               <a:spcAft>
-                <a:spcPts val="1000"/>
+                <a:spcPts val="800"/>
               </a:spcAft>
-              <a:defRPr sz="1000">
+              <a:defRPr sz="1050">
                 <a:solidFill>
                   <a:srgbClr val="64748B"/>
                 </a:solidFill>
               </a:defRPr>
             </a:pPr>
             <a:r>
-              <a:t>True Lexicographic 2-Stage Solve: Maximizes fulfillment first, then minimizes cost.</a:t>
+              <a:t>True Lexicographic 2-Stage Priority Solve: Maximizes fulfillment first, then minimizes cost.</a:t>
             </a:r>
           </a:p>
           <a:p>
             <a:pPr>
               <a:spcAft>
-                <a:spcPts val="1000"/>
+                <a:spcPts val="800"/>
               </a:spcAft>
-              <a:defRPr sz="950" b="1">
+              <a:defRPr sz="1050" b="1">
                 <a:solidFill>
                   <a:srgbClr val="0284C7"/>
                 </a:solidFill>
@@ -6341,53 +6305,14 @@
           </a:p>
           <a:p>
             <a:pPr>
-              <a:spcAft>
-                <a:spcPts val="1200"/>
-              </a:spcAft>
-              <a:defRPr sz="1000">
+              <a:defRPr sz="1050">
                 <a:solidFill>
                   <a:srgbClr val="1E293B"/>
                 </a:solidFill>
               </a:defRPr>
             </a:pPr>
             <a:r>
-              <a:t>Guarantees maximum customer service (91.74%) with globally optimal routing.</a:t>
-            </a:r>
-          </a:p>
-          <a:p>
-            <a:pPr>
-              <a:defRPr sz="900">
-                <a:solidFill>
-                  <a:srgbClr val="1E293B"/>
-                </a:solidFill>
-              </a:defRPr>
-            </a:pPr>
-            <a:r>
-              <a:t>Hard Constraints Enforced:</a:t>
-            </a:r>
-            <a:br/>
-            <a:r>
-              <a:t>• Warehouse usable supply bounds</a:t>
-            </a:r>
-            <a:br/>
-            <a:r>
-              <a:t>• Destination receiving caps (3,000 u/day)</a:t>
-            </a:r>
-            <a:br/>
-            <a:r>
-              <a:t>• Warehouse dispatch caps (15,000 u/day)</a:t>
-            </a:r>
-            <a:br/>
-            <a:r>
-              <a:t>• Active route &amp; lead-time cutoffs</a:t>
-            </a:r>
-            <a:br/>
-            <a:r>
-              <a:t>• Batch arrival shelf-life feasibility</a:t>
-            </a:r>
-            <a:br/>
-            <a:r>
-              <a:t>• Non-negative integers (x in Z+)</a:t>
+              <a:t>Guarantees maximum customer service (91.74%) with globally optimal routing ($52,812.09).</a:t>
             </a:r>
           </a:p>
         </p:txBody>
@@ -6401,7 +6326,7 @@
         <p:spPr>
           <a:xfrm>
             <a:off x="7863840" y="1371600"/>
-            <a:ext cx="3383280" cy="4892040"/>
+            <a:ext cx="3383280" cy="3931920"/>
           </a:xfrm>
           <a:prstGeom prst="roundRect">
             <a:avLst/>
@@ -6446,7 +6371,7 @@
         <p:spPr>
           <a:xfrm>
             <a:off x="8046720" y="1554480"/>
-            <a:ext cx="3017520" cy="4480560"/>
+            <a:ext cx="3017520" cy="3566160"/>
           </a:xfrm>
           <a:prstGeom prst="rect">
             <a:avLst/>
@@ -6461,7 +6386,7 @@
           <a:p>
             <a:pPr>
               <a:spcAft>
-                <a:spcPts val="400"/>
+                <a:spcPts val="300"/>
               </a:spcAft>
               <a:defRPr sz="1500" b="1">
                 <a:solidFill>
@@ -6476,86 +6401,143 @@
           <a:p>
             <a:pPr>
               <a:spcAft>
-                <a:spcPts val="1000"/>
+                <a:spcPts val="800"/>
               </a:spcAft>
+              <a:defRPr sz="1050">
+                <a:solidFill>
+                  <a:srgbClr val="64748B"/>
+                </a:solidFill>
+              </a:defRPr>
+            </a:pPr>
+            <a:r>
+              <a:t>Multi-objective formulation balancing freight, transit speed, and lost-sales penalties.</a:t>
+            </a:r>
+          </a:p>
+          <a:p>
+            <a:pPr>
+              <a:spcAft>
+                <a:spcPts val="800"/>
+              </a:spcAft>
+              <a:defRPr sz="1050" b="1">
+                <a:solidFill>
+                  <a:srgbClr val="0284C7"/>
+                </a:solidFill>
+              </a:defRPr>
+            </a:pPr>
+            <a:r>
+              <a:t>min sum[(c_wd + 0.20*T_wd)*x] + sum(5*P * u)</a:t>
+            </a:r>
+            <a:br/>
+            <a:r>
+              <a:t>Units: All terms in $/unit</a:t>
+            </a:r>
+          </a:p>
+          <a:p>
+            <a:pPr>
+              <a:defRPr sz="1050">
+                <a:solidFill>
+                  <a:srgbClr val="1E293B"/>
+                </a:solidFill>
+              </a:defRPr>
+            </a:pPr>
+            <a:r>
+              <a:t>Balances freight cost against product freshness (freshness penalty: $0.20/day/unit).</a:t>
+            </a:r>
+          </a:p>
+        </p:txBody>
+      </p:sp>
+      <p:sp>
+        <p:nvSpPr>
+          <p:cNvPr id="10" name="Rounded Rectangle 9"/>
+          <p:cNvSpPr/>
+          <p:nvPr/>
+        </p:nvSpPr>
+        <p:spPr>
+          <a:xfrm>
+            <a:off x="731520" y="5486400"/>
+            <a:ext cx="10698480" cy="1051560"/>
+          </a:xfrm>
+          <a:prstGeom prst="roundRect">
+            <a:avLst/>
+          </a:prstGeom>
+          <a:solidFill>
+            <a:srgbClr val="F1F5F9"/>
+          </a:solidFill>
+          <a:ln w="12700">
+            <a:solidFill>
+              <a:srgbClr val="CBD5E1"/>
+            </a:solidFill>
+          </a:ln>
+        </p:spPr>
+        <p:style>
+          <a:lnRef idx="1">
+            <a:schemeClr val="accent1"/>
+          </a:lnRef>
+          <a:fillRef idx="3">
+            <a:schemeClr val="accent1"/>
+          </a:fillRef>
+          <a:effectRef idx="2">
+            <a:schemeClr val="accent1"/>
+          </a:effectRef>
+          <a:fontRef idx="minor">
+            <a:schemeClr val="lt1"/>
+          </a:fontRef>
+        </p:style>
+        <p:txBody>
+          <a:bodyPr rtlCol="0" anchor="ctr"/>
+          <a:lstStyle/>
+          <a:p>
+            <a:pPr algn="ctr"/>
+          </a:p>
+        </p:txBody>
+      </p:sp>
+      <p:sp>
+        <p:nvSpPr>
+          <p:cNvPr id="11" name="TextBox 10"/>
+          <p:cNvSpPr txBox="1"/>
+          <p:nvPr/>
+        </p:nvSpPr>
+        <p:spPr>
+          <a:xfrm>
+            <a:off x="914400" y="5532120"/>
+            <a:ext cx="10332720" cy="960120"/>
+          </a:xfrm>
+          <a:prstGeom prst="rect">
+            <a:avLst/>
+          </a:prstGeom>
+          <a:noFill/>
+        </p:spPr>
+        <p:txBody>
+          <a:bodyPr wrap="square">
+            <a:spAutoFit/>
+          </a:bodyPr>
+          <a:lstStyle/>
+          <a:p>
+            <a:pPr>
+              <a:defRPr sz="1150" b="1">
+                <a:solidFill>
+                  <a:srgbClr val="0F172A"/>
+                </a:solidFill>
+              </a:defRPr>
+            </a:pPr>
+            <a:r>
+              <a:t>Mathematical Objective vs. Reported Freight Metric &amp; Hard Constraints</a:t>
+            </a:r>
+          </a:p>
+          <a:p>
+            <a:pPr>
               <a:defRPr sz="1000">
                 <a:solidFill>
-                  <a:srgbClr val="64748B"/>
-                </a:solidFill>
-              </a:defRPr>
-            </a:pPr>
-            <a:r>
-              <a:t>Multi-objective formulation balancing freight, transit speed, and lost-sales penalties.</a:t>
-            </a:r>
-          </a:p>
-          <a:p>
-            <a:pPr>
-              <a:spcAft>
-                <a:spcPts val="1000"/>
-              </a:spcAft>
-              <a:defRPr sz="950" b="1">
-                <a:solidFill>
-                  <a:srgbClr val="0284C7"/>
-                </a:solidFill>
-              </a:defRPr>
-            </a:pPr>
-            <a:r>
-              <a:t>min sum[(c_wd + lambda_LT * T_wd) * x] + sum(5 * P * u)</a:t>
+                  <a:srgbClr val="1E293B"/>
+                </a:solidFill>
+              </a:defRPr>
+            </a:pPr>
+            <a:r>
+              <a:t>• Objective value includes internal mathematical penalties (2*P*u, 0.20*T*x); reported total_transport_cost is strictly actual freight: sum(x * c_wd).</a:t>
             </a:r>
             <a:br/>
             <a:r>
-              <a:t>Units: All terms in $/unit</a:t>
-            </a:r>
-          </a:p>
-          <a:p>
-            <a:pPr>
-              <a:spcAft>
-                <a:spcPts val="1200"/>
-              </a:spcAft>
-              <a:defRPr sz="1000">
-                <a:solidFill>
-                  <a:srgbClr val="1E293B"/>
-                </a:solidFill>
-              </a:defRPr>
-            </a:pPr>
-            <a:r>
-              <a:t>Balances freight cost against product freshness (freshness penalty: $0.20/day/unit).</a:t>
-            </a:r>
-          </a:p>
-          <a:p>
-            <a:pPr>
-              <a:defRPr sz="900">
-                <a:solidFill>
-                  <a:srgbClr val="1E293B"/>
-                </a:solidFill>
-              </a:defRPr>
-            </a:pPr>
-            <a:r>
-              <a:t>Hard Constraints Enforced:</a:t>
-            </a:r>
-            <a:br/>
-            <a:r>
-              <a:t>• Warehouse usable supply bounds</a:t>
-            </a:r>
-            <a:br/>
-            <a:r>
-              <a:t>• Destination receiving caps (3,000 u/day)</a:t>
-            </a:r>
-            <a:br/>
-            <a:r>
-              <a:t>• Warehouse dispatch caps (15,000 u/day)</a:t>
-            </a:r>
-            <a:br/>
-            <a:r>
-              <a:t>• Active route &amp; lead-time cutoffs</a:t>
-            </a:r>
-            <a:br/>
-            <a:r>
-              <a:t>• Batch arrival shelf-life feasibility</a:t>
-            </a:r>
-            <a:br/>
-            <a:r>
-              <a:t>• Non-negative integers (x in Z+)</a:t>
+              <a:t>• Enforced Hard Constraints: Warehouse usable supply bounds | Route eligibility &amp; delivery cutoffs | Warehouse dispatch caps (15k u/day) | Destination receiving caps (3k u/day) | Non-negative integers (x in Z+).</a:t>
             </a:r>
           </a:p>
         </p:txBody>
@@ -6601,7 +6583,7 @@
           <a:lstStyle/>
           <a:p>
             <a:pPr>
-              <a:defRPr sz="1000" b="1">
+              <a:defRPr sz="1100" b="1">
                 <a:solidFill>
                   <a:srgbClr val="0284C7"/>
                 </a:solidFill>
@@ -6621,8 +6603,8 @@
         </p:nvSpPr>
         <p:spPr>
           <a:xfrm>
-            <a:off x="731520" y="640080"/>
-            <a:ext cx="10515600" cy="548640"/>
+            <a:off x="731520" y="658368"/>
+            <a:ext cx="10515600" cy="594360"/>
           </a:xfrm>
           <a:prstGeom prst="rect">
             <a:avLst/>
@@ -6636,7 +6618,7 @@
           <a:lstStyle/>
           <a:p>
             <a:pPr>
-              <a:defRPr sz="2200" b="1">
+              <a:defRPr sz="2300" b="1">
                 <a:solidFill>
                   <a:srgbClr val="0F172A"/>
                 </a:solidFill>
@@ -6658,7 +6640,7 @@
         </p:nvGraphicFramePr>
         <p:xfrm>
           <a:off x="731520" y="1371600"/>
-          <a:ext cx="10698480" cy="2743200"/>
+          <a:ext cx="10698480" cy="2834640"/>
         </p:xfrm>
         <a:graphic>
           <a:graphicData uri="http://schemas.openxmlformats.org/drawingml/2006/table">
@@ -6673,14 +6655,14 @@
                 <a:gridCol w="2139696"/>
                 <a:gridCol w="2139696"/>
               </a:tblGrid>
-              <a:tr h="391885">
+              <a:tr h="404948">
                 <a:tc>
                   <a:txBody>
                     <a:bodyPr/>
                     <a:lstStyle/>
                     <a:p>
                       <a:pPr>
-                        <a:defRPr sz="1000" b="1">
+                        <a:defRPr sz="1100" b="1">
                           <a:solidFill>
                             <a:srgbClr val="FFFFFF"/>
                           </a:solidFill>
@@ -6703,7 +6685,7 @@
                     <a:lstStyle/>
                     <a:p>
                       <a:pPr>
-                        <a:defRPr sz="1000" b="1">
+                        <a:defRPr sz="1100" b="1">
                           <a:solidFill>
                             <a:srgbClr val="FFFFFF"/>
                           </a:solidFill>
@@ -6726,7 +6708,7 @@
                     <a:lstStyle/>
                     <a:p>
                       <a:pPr>
-                        <a:defRPr sz="1000" b="1">
+                        <a:defRPr sz="1100" b="1">
                           <a:solidFill>
                             <a:srgbClr val="FFFFFF"/>
                           </a:solidFill>
@@ -6749,7 +6731,7 @@
                     <a:lstStyle/>
                     <a:p>
                       <a:pPr>
-                        <a:defRPr sz="1000" b="1">
+                        <a:defRPr sz="1100" b="1">
                           <a:solidFill>
                             <a:srgbClr val="FFFFFF"/>
                           </a:solidFill>
@@ -6772,7 +6754,7 @@
                     <a:lstStyle/>
                     <a:p>
                       <a:pPr>
-                        <a:defRPr sz="1000" b="1">
+                        <a:defRPr sz="1100" b="1">
                           <a:solidFill>
                             <a:srgbClr val="FFFFFF"/>
                           </a:solidFill>
@@ -6790,14 +6772,14 @@
                   </a:tcPr>
                 </a:tc>
               </a:tr>
-              <a:tr h="391885">
+              <a:tr h="404948">
                 <a:tc>
                   <a:txBody>
                     <a:bodyPr/>
                     <a:lstStyle/>
                     <a:p>
                       <a:pPr>
-                        <a:defRPr sz="1000">
+                        <a:defRPr sz="1100">
                           <a:solidFill>
                             <a:srgbClr val="0F172A"/>
                           </a:solidFill>
@@ -6820,7 +6802,7 @@
                     <a:lstStyle/>
                     <a:p>
                       <a:pPr>
-                        <a:defRPr sz="1000">
+                        <a:defRPr sz="1100">
                           <a:solidFill>
                             <a:srgbClr val="0F172A"/>
                           </a:solidFill>
@@ -6843,7 +6825,7 @@
                     <a:lstStyle/>
                     <a:p>
                       <a:pPr>
-                        <a:defRPr sz="1000">
+                        <a:defRPr sz="1100">
                           <a:solidFill>
                             <a:srgbClr val="0F172A"/>
                           </a:solidFill>
@@ -6866,7 +6848,7 @@
                     <a:lstStyle/>
                     <a:p>
                       <a:pPr>
-                        <a:defRPr sz="1000">
+                        <a:defRPr sz="1100">
                           <a:solidFill>
                             <a:srgbClr val="0F172A"/>
                           </a:solidFill>
@@ -6889,7 +6871,7 @@
                     <a:lstStyle/>
                     <a:p>
                       <a:pPr>
-                        <a:defRPr sz="1000">
+                        <a:defRPr sz="1100">
                           <a:solidFill>
                             <a:srgbClr val="0F172A"/>
                           </a:solidFill>
@@ -6907,14 +6889,14 @@
                   </a:tcPr>
                 </a:tc>
               </a:tr>
-              <a:tr h="391885">
+              <a:tr h="404948">
                 <a:tc>
                   <a:txBody>
                     <a:bodyPr/>
                     <a:lstStyle/>
                     <a:p>
                       <a:pPr>
-                        <a:defRPr sz="1000">
+                        <a:defRPr sz="1100">
                           <a:solidFill>
                             <a:srgbClr val="0F172A"/>
                           </a:solidFill>
@@ -6933,7 +6915,7 @@
                     <a:lstStyle/>
                     <a:p>
                       <a:pPr>
-                        <a:defRPr sz="1000">
+                        <a:defRPr sz="1100">
                           <a:solidFill>
                             <a:srgbClr val="0F172A"/>
                           </a:solidFill>
@@ -6952,7 +6934,7 @@
                     <a:lstStyle/>
                     <a:p>
                       <a:pPr>
-                        <a:defRPr sz="1000">
+                        <a:defRPr sz="1100">
                           <a:solidFill>
                             <a:srgbClr val="0F172A"/>
                           </a:solidFill>
@@ -6971,7 +6953,7 @@
                     <a:lstStyle/>
                     <a:p>
                       <a:pPr>
-                        <a:defRPr sz="1000">
+                        <a:defRPr sz="1100">
                           <a:solidFill>
                             <a:srgbClr val="0F172A"/>
                           </a:solidFill>
@@ -6990,7 +6972,7 @@
                     <a:lstStyle/>
                     <a:p>
                       <a:pPr>
-                        <a:defRPr sz="1000">
+                        <a:defRPr sz="1100">
                           <a:solidFill>
                             <a:srgbClr val="0F172A"/>
                           </a:solidFill>
@@ -7004,14 +6986,14 @@
                   <a:tcPr/>
                 </a:tc>
               </a:tr>
-              <a:tr h="391885">
+              <a:tr h="404948">
                 <a:tc>
                   <a:txBody>
                     <a:bodyPr/>
                     <a:lstStyle/>
                     <a:p>
                       <a:pPr>
-                        <a:defRPr sz="1000">
+                        <a:defRPr sz="1100">
                           <a:solidFill>
                             <a:srgbClr val="0F172A"/>
                           </a:solidFill>
@@ -7034,7 +7016,7 @@
                     <a:lstStyle/>
                     <a:p>
                       <a:pPr>
-                        <a:defRPr sz="1000">
+                        <a:defRPr sz="1100">
                           <a:solidFill>
                             <a:srgbClr val="0F172A"/>
                           </a:solidFill>
@@ -7057,7 +7039,7 @@
                     <a:lstStyle/>
                     <a:p>
                       <a:pPr>
-                        <a:defRPr sz="1000">
+                        <a:defRPr sz="1100">
                           <a:solidFill>
                             <a:srgbClr val="0F172A"/>
                           </a:solidFill>
@@ -7080,7 +7062,7 @@
                     <a:lstStyle/>
                     <a:p>
                       <a:pPr>
-                        <a:defRPr sz="1000">
+                        <a:defRPr sz="1100">
                           <a:solidFill>
                             <a:srgbClr val="0F172A"/>
                           </a:solidFill>
@@ -7103,7 +7085,7 @@
                     <a:lstStyle/>
                     <a:p>
                       <a:pPr>
-                        <a:defRPr sz="1000">
+                        <a:defRPr sz="1100">
                           <a:solidFill>
                             <a:srgbClr val="0F172A"/>
                           </a:solidFill>
@@ -7121,14 +7103,14 @@
                   </a:tcPr>
                 </a:tc>
               </a:tr>
-              <a:tr h="391885">
+              <a:tr h="404948">
                 <a:tc>
                   <a:txBody>
                     <a:bodyPr/>
                     <a:lstStyle/>
                     <a:p>
                       <a:pPr>
-                        <a:defRPr sz="1000">
+                        <a:defRPr sz="1100">
                           <a:solidFill>
                             <a:srgbClr val="0F172A"/>
                           </a:solidFill>
@@ -7147,7 +7129,7 @@
                     <a:lstStyle/>
                     <a:p>
                       <a:pPr>
-                        <a:defRPr sz="1000">
+                        <a:defRPr sz="1100">
                           <a:solidFill>
                             <a:srgbClr val="0F172A"/>
                           </a:solidFill>
@@ -7166,7 +7148,7 @@
                     <a:lstStyle/>
                     <a:p>
                       <a:pPr>
-                        <a:defRPr sz="1000">
+                        <a:defRPr sz="1100">
                           <a:solidFill>
                             <a:srgbClr val="0F172A"/>
                           </a:solidFill>
@@ -7185,7 +7167,7 @@
                     <a:lstStyle/>
                     <a:p>
                       <a:pPr>
-                        <a:defRPr sz="1000">
+                        <a:defRPr sz="1100">
                           <a:solidFill>
                             <a:srgbClr val="0F172A"/>
                           </a:solidFill>
@@ -7204,7 +7186,7 @@
                     <a:lstStyle/>
                     <a:p>
                       <a:pPr>
-                        <a:defRPr sz="1000">
+                        <a:defRPr sz="1100">
                           <a:solidFill>
                             <a:srgbClr val="0F172A"/>
                           </a:solidFill>
@@ -7218,14 +7200,14 @@
                   <a:tcPr/>
                 </a:tc>
               </a:tr>
-              <a:tr h="391885">
+              <a:tr h="404948">
                 <a:tc>
                   <a:txBody>
                     <a:bodyPr/>
                     <a:lstStyle/>
                     <a:p>
                       <a:pPr>
-                        <a:defRPr sz="1000">
+                        <a:defRPr sz="1100">
                           <a:solidFill>
                             <a:srgbClr val="0F172A"/>
                           </a:solidFill>
@@ -7248,7 +7230,7 @@
                     <a:lstStyle/>
                     <a:p>
                       <a:pPr>
-                        <a:defRPr sz="1000">
+                        <a:defRPr sz="1100">
                           <a:solidFill>
                             <a:srgbClr val="0F172A"/>
                           </a:solidFill>
@@ -7271,7 +7253,7 @@
                     <a:lstStyle/>
                     <a:p>
                       <a:pPr>
-                        <a:defRPr sz="1000">
+                        <a:defRPr sz="1100">
                           <a:solidFill>
                             <a:srgbClr val="0F172A"/>
                           </a:solidFill>
@@ -7294,7 +7276,7 @@
                     <a:lstStyle/>
                     <a:p>
                       <a:pPr>
-                        <a:defRPr sz="1000">
+                        <a:defRPr sz="1100">
                           <a:solidFill>
                             <a:srgbClr val="0F172A"/>
                           </a:solidFill>
@@ -7317,7 +7299,7 @@
                     <a:lstStyle/>
                     <a:p>
                       <a:pPr>
-                        <a:defRPr sz="1000">
+                        <a:defRPr sz="1100">
                           <a:solidFill>
                             <a:srgbClr val="0F172A"/>
                           </a:solidFill>
@@ -7335,14 +7317,14 @@
                   </a:tcPr>
                 </a:tc>
               </a:tr>
-              <a:tr h="391890">
+              <a:tr h="404952">
                 <a:tc>
                   <a:txBody>
                     <a:bodyPr/>
                     <a:lstStyle/>
                     <a:p>
                       <a:pPr>
-                        <a:defRPr sz="1000">
+                        <a:defRPr sz="1100">
                           <a:solidFill>
                             <a:srgbClr val="0F172A"/>
                           </a:solidFill>
@@ -7361,7 +7343,7 @@
                     <a:lstStyle/>
                     <a:p>
                       <a:pPr>
-                        <a:defRPr sz="1000">
+                        <a:defRPr sz="1100">
                           <a:solidFill>
                             <a:srgbClr val="0F172A"/>
                           </a:solidFill>
@@ -7380,7 +7362,7 @@
                     <a:lstStyle/>
                     <a:p>
                       <a:pPr>
-                        <a:defRPr sz="1000">
+                        <a:defRPr sz="1100">
                           <a:solidFill>
                             <a:srgbClr val="0F172A"/>
                           </a:solidFill>
@@ -7399,7 +7381,7 @@
                     <a:lstStyle/>
                     <a:p>
                       <a:pPr>
-                        <a:defRPr sz="1000">
+                        <a:defRPr sz="1100">
                           <a:solidFill>
                             <a:srgbClr val="0F172A"/>
                           </a:solidFill>
@@ -7418,7 +7400,7 @@
                     <a:lstStyle/>
                     <a:p>
                       <a:pPr>
-                        <a:defRPr sz="1000">
+                        <a:defRPr sz="1100">
                           <a:solidFill>
                             <a:srgbClr val="0F172A"/>
                           </a:solidFill>
@@ -7444,8 +7426,8 @@
         </p:nvSpPr>
         <p:spPr>
           <a:xfrm>
-            <a:off x="731520" y="4389120"/>
-            <a:ext cx="10698480" cy="1920240"/>
+            <a:off x="731520" y="4434840"/>
+            <a:ext cx="10698480" cy="2103120"/>
           </a:xfrm>
           <a:prstGeom prst="roundRect">
             <a:avLst/>
@@ -7489,8 +7471,8 @@
         </p:nvSpPr>
         <p:spPr>
           <a:xfrm>
-            <a:off x="914400" y="4480560"/>
-            <a:ext cx="10332720" cy="1737360"/>
+            <a:off x="914400" y="4526280"/>
+            <a:ext cx="10332720" cy="1920240"/>
           </a:xfrm>
           <a:prstGeom prst="rect">
             <a:avLst/>
@@ -7507,7 +7489,7 @@
               <a:spcAft>
                 <a:spcPts val="400"/>
               </a:spcAft>
-              <a:defRPr sz="1300" b="1">
+              <a:defRPr sz="1350" b="1">
                 <a:solidFill>
                   <a:srgbClr val="0284C7"/>
                 </a:solidFill>
@@ -7519,7 +7501,10 @@
           </a:p>
           <a:p>
             <a:pPr>
-              <a:defRPr sz="1000">
+              <a:spcAft>
+                <a:spcPts val="300"/>
+              </a:spcAft>
+              <a:defRPr sz="1100">
                 <a:solidFill>
                   <a:srgbClr val="1E293B"/>
                 </a:solidFill>
@@ -7531,7 +7516,10 @@
           </a:p>
           <a:p>
             <a:pPr>
-              <a:defRPr sz="1000">
+              <a:spcAft>
+                <a:spcPts val="300"/>
+              </a:spcAft>
+              <a:defRPr sz="1100">
                 <a:solidFill>
                   <a:srgbClr val="1E293B"/>
                 </a:solidFill>
@@ -7543,7 +7531,7 @@
           </a:p>
           <a:p>
             <a:pPr>
-              <a:defRPr sz="1000">
+              <a:defRPr sz="1100">
                 <a:solidFill>
                   <a:srgbClr val="1E293B"/>
                 </a:solidFill>
@@ -7596,7 +7584,7 @@
           <a:lstStyle/>
           <a:p>
             <a:pPr>
-              <a:defRPr sz="1000" b="1">
+              <a:defRPr sz="1100" b="1">
                 <a:solidFill>
                   <a:srgbClr val="0284C7"/>
                 </a:solidFill>
@@ -7616,8 +7604,8 @@
         </p:nvSpPr>
         <p:spPr>
           <a:xfrm>
-            <a:off x="731520" y="640080"/>
-            <a:ext cx="10515600" cy="548640"/>
+            <a:off x="731520" y="658368"/>
+            <a:ext cx="10515600" cy="594360"/>
           </a:xfrm>
           <a:prstGeom prst="rect">
             <a:avLst/>
@@ -7631,7 +7619,7 @@
           <a:lstStyle/>
           <a:p>
             <a:pPr>
-              <a:defRPr sz="2200" b="1">
+              <a:defRPr sz="2300" b="1">
                 <a:solidFill>
                   <a:srgbClr val="0F172A"/>
                 </a:solidFill>
@@ -7712,9 +7700,9 @@
           <a:p>
             <a:pPr>
               <a:spcAft>
-                <a:spcPts val="600"/>
+                <a:spcPts val="800"/>
               </a:spcAft>
-              <a:defRPr sz="1500" b="1">
+              <a:defRPr sz="1600" b="1">
                 <a:solidFill>
                   <a:srgbClr val="0F172A"/>
                 </a:solidFill>
@@ -7726,7 +7714,7 @@
           </a:p>
           <a:p>
             <a:pPr>
-              <a:defRPr sz="950">
+              <a:defRPr sz="1050">
                 <a:solidFill>
                   <a:srgbClr val="16A34A"/>
                 </a:solidFill>
@@ -7738,7 +7726,7 @@
           </a:p>
           <a:p>
             <a:pPr>
-              <a:defRPr sz="950">
+              <a:defRPr sz="1050">
                 <a:solidFill>
                   <a:srgbClr val="16A34A"/>
                 </a:solidFill>
@@ -7750,7 +7738,7 @@
           </a:p>
           <a:p>
             <a:pPr>
-              <a:defRPr sz="950">
+              <a:defRPr sz="1050">
                 <a:solidFill>
                   <a:srgbClr val="16A34A"/>
                 </a:solidFill>
@@ -7762,7 +7750,7 @@
           </a:p>
           <a:p>
             <a:pPr>
-              <a:defRPr sz="950">
+              <a:defRPr sz="1050">
                 <a:solidFill>
                   <a:srgbClr val="16A34A"/>
                 </a:solidFill>
@@ -7774,7 +7762,7 @@
           </a:p>
           <a:p>
             <a:pPr>
-              <a:defRPr sz="950">
+              <a:defRPr sz="1050">
                 <a:solidFill>
                   <a:srgbClr val="16A34A"/>
                 </a:solidFill>
@@ -7786,7 +7774,7 @@
           </a:p>
           <a:p>
             <a:pPr>
-              <a:defRPr sz="950">
+              <a:defRPr sz="1050">
                 <a:solidFill>
                   <a:srgbClr val="16A34A"/>
                 </a:solidFill>
@@ -7798,7 +7786,7 @@
           </a:p>
           <a:p>
             <a:pPr>
-              <a:defRPr sz="950">
+              <a:defRPr sz="1050">
                 <a:solidFill>
                   <a:srgbClr val="16A34A"/>
                 </a:solidFill>
@@ -7810,7 +7798,7 @@
           </a:p>
           <a:p>
             <a:pPr>
-              <a:defRPr sz="950">
+              <a:defRPr sz="1050">
                 <a:solidFill>
                   <a:srgbClr val="16A34A"/>
                 </a:solidFill>
@@ -7822,7 +7810,7 @@
           </a:p>
           <a:p>
             <a:pPr>
-              <a:defRPr sz="950">
+              <a:defRPr sz="1050">
                 <a:solidFill>
                   <a:srgbClr val="16A34A"/>
                 </a:solidFill>
@@ -7834,7 +7822,7 @@
           </a:p>
           <a:p>
             <a:pPr>
-              <a:defRPr sz="950">
+              <a:defRPr sz="1050">
                 <a:solidFill>
                   <a:srgbClr val="16A34A"/>
                 </a:solidFill>
@@ -7846,7 +7834,7 @@
           </a:p>
           <a:p>
             <a:pPr>
-              <a:defRPr sz="950">
+              <a:defRPr sz="1050">
                 <a:solidFill>
                   <a:srgbClr val="16A34A"/>
                 </a:solidFill>
@@ -7858,7 +7846,7 @@
           </a:p>
           <a:p>
             <a:pPr>
-              <a:defRPr sz="950">
+              <a:defRPr sz="1050">
                 <a:solidFill>
                   <a:srgbClr val="16A34A"/>
                 </a:solidFill>
@@ -7941,7 +7929,7 @@
               <a:spcAft>
                 <a:spcPts val="800"/>
               </a:spcAft>
-              <a:defRPr sz="1500" b="1">
+              <a:defRPr sz="1600" b="1">
                 <a:solidFill>
                   <a:srgbClr val="0F172A"/>
                 </a:solidFill>
@@ -7953,7 +7941,7 @@
           </a:p>
           <a:p>
             <a:pPr>
-              <a:defRPr sz="1050" b="1">
+              <a:defRPr sz="1150" b="1">
                 <a:solidFill>
                   <a:srgbClr val="0284C7"/>
                 </a:solidFill>
@@ -7966,9 +7954,9 @@
           <a:p>
             <a:pPr>
               <a:spcAft>
-                <a:spcPts val="600"/>
+                <a:spcPts val="800"/>
               </a:spcAft>
-              <a:defRPr sz="950">
+              <a:defRPr sz="1050">
                 <a:solidFill>
                   <a:srgbClr val="1E293B"/>
                 </a:solidFill>
@@ -7980,7 +7968,7 @@
           </a:p>
           <a:p>
             <a:pPr>
-              <a:defRPr sz="1050" b="1">
+              <a:defRPr sz="1150" b="1">
                 <a:solidFill>
                   <a:srgbClr val="0284C7"/>
                 </a:solidFill>
@@ -7993,9 +7981,9 @@
           <a:p>
             <a:pPr>
               <a:spcAft>
-                <a:spcPts val="600"/>
+                <a:spcPts val="800"/>
               </a:spcAft>
-              <a:defRPr sz="950">
+              <a:defRPr sz="1050">
                 <a:solidFill>
                   <a:srgbClr val="1E293B"/>
                 </a:solidFill>
@@ -8007,7 +7995,7 @@
           </a:p>
           <a:p>
             <a:pPr>
-              <a:defRPr sz="1050" b="1">
+              <a:defRPr sz="1150" b="1">
                 <a:solidFill>
                   <a:srgbClr val="0284C7"/>
                 </a:solidFill>
@@ -8020,9 +8008,9 @@
           <a:p>
             <a:pPr>
               <a:spcAft>
-                <a:spcPts val="600"/>
+                <a:spcPts val="800"/>
               </a:spcAft>
-              <a:defRPr sz="950">
+              <a:defRPr sz="1050">
                 <a:solidFill>
                   <a:srgbClr val="1E293B"/>
                 </a:solidFill>
@@ -8034,7 +8022,7 @@
           </a:p>
           <a:p>
             <a:pPr>
-              <a:defRPr sz="1050" b="1">
+              <a:defRPr sz="1150" b="1">
                 <a:solidFill>
                   <a:srgbClr val="0284C7"/>
                 </a:solidFill>
@@ -8047,9 +8035,9 @@
           <a:p>
             <a:pPr>
               <a:spcAft>
-                <a:spcPts val="600"/>
+                <a:spcPts val="800"/>
               </a:spcAft>
-              <a:defRPr sz="950">
+              <a:defRPr sz="1050">
                 <a:solidFill>
                   <a:srgbClr val="1E293B"/>
                 </a:solidFill>
@@ -8102,7 +8090,7 @@
           <a:lstStyle/>
           <a:p>
             <a:pPr>
-              <a:defRPr sz="1000" b="1">
+              <a:defRPr sz="1100" b="1">
                 <a:solidFill>
                   <a:srgbClr val="0284C7"/>
                 </a:solidFill>
@@ -8122,8 +8110,8 @@
         </p:nvSpPr>
         <p:spPr>
           <a:xfrm>
-            <a:off x="731520" y="640080"/>
-            <a:ext cx="10515600" cy="548640"/>
+            <a:off x="731520" y="658368"/>
+            <a:ext cx="10515600" cy="594360"/>
           </a:xfrm>
           <a:prstGeom prst="rect">
             <a:avLst/>
@@ -8137,7 +8125,7 @@
           <a:lstStyle/>
           <a:p>
             <a:pPr>
-              <a:defRPr sz="2200" b="1">
+              <a:defRPr sz="2300" b="1">
                 <a:solidFill>
                   <a:srgbClr val="0F172A"/>
                 </a:solidFill>
@@ -8217,7 +8205,7 @@
           <a:lstStyle/>
           <a:p>
             <a:pPr>
-              <a:defRPr sz="1300" b="1">
+              <a:defRPr sz="1350" b="1">
                 <a:solidFill>
                   <a:srgbClr val="0F172A"/>
                 </a:solidFill>
@@ -8232,7 +8220,7 @@
               <a:spcAft>
                 <a:spcPts val="600"/>
               </a:spcAft>
-              <a:defRPr sz="950" b="1">
+              <a:defRPr sz="1050" b="1">
                 <a:solidFill>
                   <a:srgbClr val="0284C7"/>
                 </a:solidFill>
@@ -8244,7 +8232,7 @@
           </a:p>
           <a:p>
             <a:pPr>
-              <a:defRPr sz="950">
+              <a:defRPr sz="1050">
                 <a:solidFill>
                   <a:srgbClr val="1E293B"/>
                 </a:solidFill>
@@ -8324,7 +8312,7 @@
           <a:lstStyle/>
           <a:p>
             <a:pPr>
-              <a:defRPr sz="1300" b="1">
+              <a:defRPr sz="1350" b="1">
                 <a:solidFill>
                   <a:srgbClr val="0F172A"/>
                 </a:solidFill>
@@ -8339,7 +8327,7 @@
               <a:spcAft>
                 <a:spcPts val="600"/>
               </a:spcAft>
-              <a:defRPr sz="950" b="1">
+              <a:defRPr sz="1050" b="1">
                 <a:solidFill>
                   <a:srgbClr val="0284C7"/>
                 </a:solidFill>
@@ -8351,7 +8339,7 @@
           </a:p>
           <a:p>
             <a:pPr>
-              <a:defRPr sz="950">
+              <a:defRPr sz="1050">
                 <a:solidFill>
                   <a:srgbClr val="1E293B"/>
                 </a:solidFill>
@@ -8431,7 +8419,7 @@
           <a:lstStyle/>
           <a:p>
             <a:pPr>
-              <a:defRPr sz="1300" b="1">
+              <a:defRPr sz="1350" b="1">
                 <a:solidFill>
                   <a:srgbClr val="0F172A"/>
                 </a:solidFill>
@@ -8446,7 +8434,7 @@
               <a:spcAft>
                 <a:spcPts val="600"/>
               </a:spcAft>
-              <a:defRPr sz="950" b="1">
+              <a:defRPr sz="1050" b="1">
                 <a:solidFill>
                   <a:srgbClr val="0284C7"/>
                 </a:solidFill>
@@ -8458,14 +8446,14 @@
           </a:p>
           <a:p>
             <a:pPr>
-              <a:defRPr sz="950">
+              <a:defRPr sz="1050">
                 <a:solidFill>
                   <a:srgbClr val="1E293B"/>
                 </a:solidFill>
               </a:defRPr>
             </a:pPr>
             <a:r>
-              <a:t>Select corridor PRD-MILK -&gt; DST-001. Run EWMA (alpha=0.30) 7-day forecast. Display Recharts projection curve and backtest holdout evaluation (MAE/WAPE).</a:t>
+              <a:t>Select Corridor SKU-0001 (Whole Milk) -&gt; DST-01 (Sacramento). Run EWMA (alpha=0.30) 7-day forecast. Display Recharts curve and backtest holdout evaluation (MAE/WAPE).</a:t>
             </a:r>
           </a:p>
         </p:txBody>
@@ -8538,7 +8526,7 @@
           <a:lstStyle/>
           <a:p>
             <a:pPr>
-              <a:defRPr sz="1300" b="1">
+              <a:defRPr sz="1350" b="1">
                 <a:solidFill>
                   <a:srgbClr val="0F172A"/>
                 </a:solidFill>
@@ -8553,7 +8541,7 @@
               <a:spcAft>
                 <a:spcPts val="600"/>
               </a:spcAft>
-              <a:defRPr sz="950" b="1">
+              <a:defRPr sz="1050" b="1">
                 <a:solidFill>
                   <a:srgbClr val="0284C7"/>
                 </a:solidFill>
@@ -8565,7 +8553,7 @@
           </a:p>
           <a:p>
             <a:pPr>
-              <a:defRPr sz="950">
+              <a:defRPr sz="1050">
                 <a:solidFill>
                   <a:srgbClr val="1E293B"/>
                 </a:solidFill>
@@ -8645,7 +8633,7 @@
           <a:lstStyle/>
           <a:p>
             <a:pPr>
-              <a:defRPr sz="1300" b="1">
+              <a:defRPr sz="1350" b="1">
                 <a:solidFill>
                   <a:srgbClr val="0F172A"/>
                 </a:solidFill>
@@ -8660,7 +8648,7 @@
               <a:spcAft>
                 <a:spcPts val="600"/>
               </a:spcAft>
-              <a:defRPr sz="950" b="1">
+              <a:defRPr sz="1050" b="1">
                 <a:solidFill>
                   <a:srgbClr val="0284C7"/>
                 </a:solidFill>
@@ -8672,7 +8660,7 @@
           </a:p>
           <a:p>
             <a:pPr>
-              <a:defRPr sz="950">
+              <a:defRPr sz="1050">
                 <a:solidFill>
                   <a:srgbClr val="1E293B"/>
                 </a:solidFill>
@@ -8752,7 +8740,7 @@
           <a:lstStyle/>
           <a:p>
             <a:pPr>
-              <a:defRPr sz="1300" b="1">
+              <a:defRPr sz="1350" b="1">
                 <a:solidFill>
                   <a:srgbClr val="0F172A"/>
                 </a:solidFill>
@@ -8767,7 +8755,7 @@
               <a:spcAft>
                 <a:spcPts val="600"/>
               </a:spcAft>
-              <a:defRPr sz="950" b="1">
+              <a:defRPr sz="1050" b="1">
                 <a:solidFill>
                   <a:srgbClr val="0284C7"/>
                 </a:solidFill>
@@ -8779,7 +8767,7 @@
           </a:p>
           <a:p>
             <a:pPr>
-              <a:defRPr sz="950">
+              <a:defRPr sz="1050">
                 <a:solidFill>
                   <a:srgbClr val="1E293B"/>
                 </a:solidFill>

</xml_diff>